<commit_message>
slides(babi): enlarge answers and simplify paper references
</commit_message>
<xml_diff>
--- a/slides/datasets-in-10-minutes-babi.pptx
+++ b/slides/datasets-in-10-minutes-babi.pptx
@@ -7440,8 +7440,8 @@
         </p:nvSpPr>
         <p:spPr>
           <a:xfrm>
-            <a:off x="6583680" y="1271016"/>
-            <a:ext cx="1965960" cy="201168"/>
+            <a:off x="5303520" y="1216152"/>
+            <a:ext cx="3246120" cy="384048"/>
           </a:xfrm>
           <a:prstGeom prst="rect">
             <a:avLst/>
@@ -7449,14 +7449,14 @@
           <a:noFill/>
         </p:spPr>
         <p:txBody>
-          <a:bodyPr wrap="square" lIns="0" rIns="0" tIns="0" bIns="0">
+          <a:bodyPr wrap="none" lIns="0" rIns="0" tIns="0" bIns="0">
             <a:noAutofit/>
           </a:bodyPr>
           <a:lstStyle/>
           <a:p>
-            <a:pPr algn="l">
-              <a:lnSpc>
-                <a:spcPct val="117000"/>
+            <a:pPr algn="r">
+              <a:lnSpc>
+                <a:spcPts val="2640"/>
               </a:lnSpc>
               <a:spcBef>
                 <a:spcPts val="0"/>
@@ -7473,7 +7473,7 @@
               </a:defRPr>
             </a:pPr>
             <a:r>
-              <a:rPr sz="1250" b="1" lang="ja-JP" altLang="en-US">
+              <a:rPr sz="2200" b="1" lang="ja-JP" altLang="en-US">
                 <a:solidFill>
                   <a:srgbClr val="2C9100"/>
                 </a:solidFill>
@@ -10672,7 +10672,7 @@
                 <a:ea typeface="Noto Sans CJK JP"/>
                 <a:cs typeface="Noto Sans"/>
               </a:rPr>
-              <a:t>2015年の論文Table 3。MemNN拡張は根拠の事実も教師に使う。</a:t>
+              <a:t>MemNN拡張は根拠の事実も教師に使う。</a:t>
             </a:r>
           </a:p>
         </p:txBody>
@@ -13521,8 +13521,8 @@
         </p:nvSpPr>
         <p:spPr>
           <a:xfrm>
-            <a:off x="6583680" y="1271016"/>
-            <a:ext cx="1965960" cy="201168"/>
+            <a:off x="5303520" y="1216152"/>
+            <a:ext cx="3246120" cy="384048"/>
           </a:xfrm>
           <a:prstGeom prst="rect">
             <a:avLst/>
@@ -13530,14 +13530,14 @@
           <a:noFill/>
         </p:spPr>
         <p:txBody>
-          <a:bodyPr wrap="square" lIns="0" rIns="0" tIns="0" bIns="0">
+          <a:bodyPr wrap="none" lIns="0" rIns="0" tIns="0" bIns="0">
             <a:noAutofit/>
           </a:bodyPr>
           <a:lstStyle/>
           <a:p>
-            <a:pPr algn="l">
-              <a:lnSpc>
-                <a:spcPct val="117000"/>
+            <a:pPr algn="r">
+              <a:lnSpc>
+                <a:spcPts val="2640"/>
               </a:lnSpc>
               <a:spcBef>
                 <a:spcPts val="0"/>
@@ -13554,7 +13554,7 @@
               </a:defRPr>
             </a:pPr>
             <a:r>
-              <a:rPr sz="1250" b="1" lang="ja-JP" altLang="en-US">
+              <a:rPr sz="2200" b="1" lang="ja-JP" altLang="en-US">
                 <a:solidFill>
                   <a:srgbClr val="2C9100"/>
                 </a:solidFill>
@@ -14134,8 +14134,8 @@
         </p:nvSpPr>
         <p:spPr>
           <a:xfrm>
-            <a:off x="6583680" y="1271016"/>
-            <a:ext cx="1965960" cy="201168"/>
+            <a:off x="5303520" y="1216152"/>
+            <a:ext cx="3246120" cy="384048"/>
           </a:xfrm>
           <a:prstGeom prst="rect">
             <a:avLst/>
@@ -14143,14 +14143,14 @@
           <a:noFill/>
         </p:spPr>
         <p:txBody>
-          <a:bodyPr wrap="square" lIns="0" rIns="0" tIns="0" bIns="0">
+          <a:bodyPr wrap="none" lIns="0" rIns="0" tIns="0" bIns="0">
             <a:noAutofit/>
           </a:bodyPr>
           <a:lstStyle/>
           <a:p>
-            <a:pPr algn="l">
-              <a:lnSpc>
-                <a:spcPct val="117000"/>
+            <a:pPr algn="r">
+              <a:lnSpc>
+                <a:spcPts val="2640"/>
               </a:lnSpc>
               <a:spcBef>
                 <a:spcPts val="0"/>
@@ -14167,7 +14167,7 @@
               </a:defRPr>
             </a:pPr>
             <a:r>
-              <a:rPr sz="1250" b="1" lang="ja-JP" altLang="en-US">
+              <a:rPr sz="2200" b="1" lang="ja-JP" altLang="en-US">
                 <a:solidFill>
                   <a:srgbClr val="2C9100"/>
                 </a:solidFill>
@@ -14880,8 +14880,8 @@
         </p:nvSpPr>
         <p:spPr>
           <a:xfrm>
-            <a:off x="6583680" y="1271016"/>
-            <a:ext cx="1965960" cy="201168"/>
+            <a:off x="5303520" y="1216152"/>
+            <a:ext cx="3246120" cy="384048"/>
           </a:xfrm>
           <a:prstGeom prst="rect">
             <a:avLst/>
@@ -14889,14 +14889,14 @@
           <a:noFill/>
         </p:spPr>
         <p:txBody>
-          <a:bodyPr wrap="square" lIns="0" rIns="0" tIns="0" bIns="0">
+          <a:bodyPr wrap="none" lIns="0" rIns="0" tIns="0" bIns="0">
             <a:noAutofit/>
           </a:bodyPr>
           <a:lstStyle/>
           <a:p>
-            <a:pPr algn="l">
-              <a:lnSpc>
-                <a:spcPct val="117000"/>
+            <a:pPr algn="r">
+              <a:lnSpc>
+                <a:spcPts val="2640"/>
               </a:lnSpc>
               <a:spcBef>
                 <a:spcPts val="0"/>
@@ -14913,7 +14913,7 @@
               </a:defRPr>
             </a:pPr>
             <a:r>
-              <a:rPr sz="1250" b="1" lang="ja-JP" altLang="en-US">
+              <a:rPr sz="2200" b="1" lang="ja-JP" altLang="en-US">
                 <a:solidFill>
                   <a:srgbClr val="2C9100"/>
                 </a:solidFill>
@@ -15493,8 +15493,8 @@
         </p:nvSpPr>
         <p:spPr>
           <a:xfrm>
-            <a:off x="6583680" y="1271016"/>
-            <a:ext cx="1965960" cy="201168"/>
+            <a:off x="5303520" y="1216152"/>
+            <a:ext cx="3246120" cy="384048"/>
           </a:xfrm>
           <a:prstGeom prst="rect">
             <a:avLst/>
@@ -15502,14 +15502,14 @@
           <a:noFill/>
         </p:spPr>
         <p:txBody>
-          <a:bodyPr wrap="square" lIns="0" rIns="0" tIns="0" bIns="0">
+          <a:bodyPr wrap="none" lIns="0" rIns="0" tIns="0" bIns="0">
             <a:noAutofit/>
           </a:bodyPr>
           <a:lstStyle/>
           <a:p>
-            <a:pPr algn="l">
-              <a:lnSpc>
-                <a:spcPct val="117000"/>
+            <a:pPr algn="r">
+              <a:lnSpc>
+                <a:spcPts val="2640"/>
               </a:lnSpc>
               <a:spcBef>
                 <a:spcPts val="0"/>
@@ -15526,7 +15526,7 @@
               </a:defRPr>
             </a:pPr>
             <a:r>
-              <a:rPr sz="1250" b="1" lang="ja-JP" altLang="en-US">
+              <a:rPr sz="2200" b="1" lang="ja-JP" altLang="en-US">
                 <a:solidFill>
                   <a:srgbClr val="2C9100"/>
                 </a:solidFill>
@@ -16106,8 +16106,8 @@
         </p:nvSpPr>
         <p:spPr>
           <a:xfrm>
-            <a:off x="6583680" y="1271016"/>
-            <a:ext cx="1965960" cy="201168"/>
+            <a:off x="5303520" y="1216152"/>
+            <a:ext cx="3246120" cy="384048"/>
           </a:xfrm>
           <a:prstGeom prst="rect">
             <a:avLst/>
@@ -16115,14 +16115,14 @@
           <a:noFill/>
         </p:spPr>
         <p:txBody>
-          <a:bodyPr wrap="square" lIns="0" rIns="0" tIns="0" bIns="0">
+          <a:bodyPr wrap="none" lIns="0" rIns="0" tIns="0" bIns="0">
             <a:noAutofit/>
           </a:bodyPr>
           <a:lstStyle/>
           <a:p>
-            <a:pPr algn="l">
-              <a:lnSpc>
-                <a:spcPct val="117000"/>
+            <a:pPr algn="r">
+              <a:lnSpc>
+                <a:spcPts val="2640"/>
               </a:lnSpc>
               <a:spcBef>
                 <a:spcPts val="0"/>
@@ -16139,7 +16139,7 @@
               </a:defRPr>
             </a:pPr>
             <a:r>
-              <a:rPr sz="1250" b="1" lang="ja-JP" altLang="en-US">
+              <a:rPr sz="2200" b="1" lang="ja-JP" altLang="en-US">
                 <a:solidFill>
                   <a:srgbClr val="2C9100"/>
                 </a:solidFill>
@@ -16719,8 +16719,8 @@
         </p:nvSpPr>
         <p:spPr>
           <a:xfrm>
-            <a:off x="6583680" y="1271016"/>
-            <a:ext cx="1965960" cy="201168"/>
+            <a:off x="5303520" y="1216152"/>
+            <a:ext cx="3246120" cy="384048"/>
           </a:xfrm>
           <a:prstGeom prst="rect">
             <a:avLst/>
@@ -16728,14 +16728,14 @@
           <a:noFill/>
         </p:spPr>
         <p:txBody>
-          <a:bodyPr wrap="square" lIns="0" rIns="0" tIns="0" bIns="0">
+          <a:bodyPr wrap="none" lIns="0" rIns="0" tIns="0" bIns="0">
             <a:noAutofit/>
           </a:bodyPr>
           <a:lstStyle/>
           <a:p>
-            <a:pPr algn="l">
-              <a:lnSpc>
-                <a:spcPct val="117000"/>
+            <a:pPr algn="r">
+              <a:lnSpc>
+                <a:spcPts val="2640"/>
               </a:lnSpc>
               <a:spcBef>
                 <a:spcPts val="0"/>
@@ -16752,7 +16752,7 @@
               </a:defRPr>
             </a:pPr>
             <a:r>
-              <a:rPr sz="1250" b="1" lang="ja-JP" altLang="en-US">
+              <a:rPr sz="2200" b="1" lang="ja-JP" altLang="en-US">
                 <a:solidFill>
                   <a:srgbClr val="2C9100"/>
                 </a:solidFill>
@@ -17332,8 +17332,8 @@
         </p:nvSpPr>
         <p:spPr>
           <a:xfrm>
-            <a:off x="6583680" y="1271016"/>
-            <a:ext cx="1965960" cy="201168"/>
+            <a:off x="5303520" y="1216152"/>
+            <a:ext cx="3246120" cy="384048"/>
           </a:xfrm>
           <a:prstGeom prst="rect">
             <a:avLst/>
@@ -17341,14 +17341,14 @@
           <a:noFill/>
         </p:spPr>
         <p:txBody>
-          <a:bodyPr wrap="square" lIns="0" rIns="0" tIns="0" bIns="0">
+          <a:bodyPr wrap="none" lIns="0" rIns="0" tIns="0" bIns="0">
             <a:noAutofit/>
           </a:bodyPr>
           <a:lstStyle/>
           <a:p>
-            <a:pPr algn="l">
-              <a:lnSpc>
-                <a:spcPct val="117000"/>
+            <a:pPr algn="r">
+              <a:lnSpc>
+                <a:spcPts val="2640"/>
               </a:lnSpc>
               <a:spcBef>
                 <a:spcPts val="0"/>
@@ -17365,7 +17365,7 @@
               </a:defRPr>
             </a:pPr>
             <a:r>
-              <a:rPr sz="1250" b="1" lang="ja-JP" altLang="en-US">
+              <a:rPr sz="2200" b="1" lang="ja-JP" altLang="en-US">
                 <a:solidFill>
                   <a:srgbClr val="2C9100"/>
                 </a:solidFill>
@@ -17945,8 +17945,8 @@
         </p:nvSpPr>
         <p:spPr>
           <a:xfrm>
-            <a:off x="6583680" y="1271016"/>
-            <a:ext cx="1965960" cy="201168"/>
+            <a:off x="5303520" y="1216152"/>
+            <a:ext cx="3246120" cy="384048"/>
           </a:xfrm>
           <a:prstGeom prst="rect">
             <a:avLst/>
@@ -17954,14 +17954,14 @@
           <a:noFill/>
         </p:spPr>
         <p:txBody>
-          <a:bodyPr wrap="square" lIns="0" rIns="0" tIns="0" bIns="0">
+          <a:bodyPr wrap="none" lIns="0" rIns="0" tIns="0" bIns="0">
             <a:noAutofit/>
           </a:bodyPr>
           <a:lstStyle/>
           <a:p>
-            <a:pPr algn="l">
-              <a:lnSpc>
-                <a:spcPct val="117000"/>
+            <a:pPr algn="r">
+              <a:lnSpc>
+                <a:spcPts val="2640"/>
               </a:lnSpc>
               <a:spcBef>
                 <a:spcPts val="0"/>
@@ -17978,7 +17978,7 @@
               </a:defRPr>
             </a:pPr>
             <a:r>
-              <a:rPr sz="1250" b="1" lang="ja-JP" altLang="en-US">
+              <a:rPr sz="2200" b="1" lang="ja-JP" altLang="en-US">
                 <a:solidFill>
                   <a:srgbClr val="2C9100"/>
                 </a:solidFill>
@@ -18558,8 +18558,8 @@
         </p:nvSpPr>
         <p:spPr>
           <a:xfrm>
-            <a:off x="6583680" y="1271016"/>
-            <a:ext cx="1965960" cy="201168"/>
+            <a:off x="5303520" y="1216152"/>
+            <a:ext cx="3246120" cy="384048"/>
           </a:xfrm>
           <a:prstGeom prst="rect">
             <a:avLst/>
@@ -18567,14 +18567,14 @@
           <a:noFill/>
         </p:spPr>
         <p:txBody>
-          <a:bodyPr wrap="square" lIns="0" rIns="0" tIns="0" bIns="0">
+          <a:bodyPr wrap="none" lIns="0" rIns="0" tIns="0" bIns="0">
             <a:noAutofit/>
           </a:bodyPr>
           <a:lstStyle/>
           <a:p>
-            <a:pPr algn="l">
-              <a:lnSpc>
-                <a:spcPct val="117000"/>
+            <a:pPr algn="r">
+              <a:lnSpc>
+                <a:spcPts val="2640"/>
               </a:lnSpc>
               <a:spcBef>
                 <a:spcPts val="0"/>
@@ -18591,7 +18591,7 @@
               </a:defRPr>
             </a:pPr>
             <a:r>
-              <a:rPr sz="1250" b="1" lang="ja-JP" altLang="en-US">
+              <a:rPr sz="2200" b="1" lang="ja-JP" altLang="en-US">
                 <a:solidFill>
                   <a:srgbClr val="2C9100"/>
                 </a:solidFill>
@@ -19171,8 +19171,8 @@
         </p:nvSpPr>
         <p:spPr>
           <a:xfrm>
-            <a:off x="6583680" y="1271016"/>
-            <a:ext cx="1965960" cy="201168"/>
+            <a:off x="5303520" y="1216152"/>
+            <a:ext cx="3246120" cy="384048"/>
           </a:xfrm>
           <a:prstGeom prst="rect">
             <a:avLst/>
@@ -19180,14 +19180,14 @@
           <a:noFill/>
         </p:spPr>
         <p:txBody>
-          <a:bodyPr wrap="square" lIns="0" rIns="0" tIns="0" bIns="0">
+          <a:bodyPr wrap="none" lIns="0" rIns="0" tIns="0" bIns="0">
             <a:noAutofit/>
           </a:bodyPr>
           <a:lstStyle/>
           <a:p>
-            <a:pPr algn="l">
-              <a:lnSpc>
-                <a:spcPct val="117000"/>
+            <a:pPr algn="r">
+              <a:lnSpc>
+                <a:spcPts val="2640"/>
               </a:lnSpc>
               <a:spcBef>
                 <a:spcPts val="0"/>
@@ -19204,7 +19204,7 @@
               </a:defRPr>
             </a:pPr>
             <a:r>
-              <a:rPr sz="1250" b="1" lang="ja-JP" altLang="en-US">
+              <a:rPr sz="2200" b="1" lang="ja-JP" altLang="en-US">
                 <a:solidFill>
                   <a:srgbClr val="2C9100"/>
                 </a:solidFill>
@@ -20032,8 +20032,8 @@
         </p:nvSpPr>
         <p:spPr>
           <a:xfrm>
-            <a:off x="6583680" y="1271016"/>
-            <a:ext cx="1965960" cy="201168"/>
+            <a:off x="5303520" y="1216152"/>
+            <a:ext cx="3246120" cy="384048"/>
           </a:xfrm>
           <a:prstGeom prst="rect">
             <a:avLst/>
@@ -20041,14 +20041,14 @@
           <a:noFill/>
         </p:spPr>
         <p:txBody>
-          <a:bodyPr wrap="square" lIns="0" rIns="0" tIns="0" bIns="0">
+          <a:bodyPr wrap="none" lIns="0" rIns="0" tIns="0" bIns="0">
             <a:noAutofit/>
           </a:bodyPr>
           <a:lstStyle/>
           <a:p>
-            <a:pPr algn="l">
-              <a:lnSpc>
-                <a:spcPct val="117000"/>
+            <a:pPr algn="r">
+              <a:lnSpc>
+                <a:spcPts val="2640"/>
               </a:lnSpc>
               <a:spcBef>
                 <a:spcPts val="0"/>
@@ -20065,7 +20065,7 @@
               </a:defRPr>
             </a:pPr>
             <a:r>
-              <a:rPr sz="1250" b="1" lang="ja-JP" altLang="en-US">
+              <a:rPr sz="2200" b="1" lang="ja-JP" altLang="en-US">
                 <a:solidFill>
                   <a:srgbClr val="2C9100"/>
                 </a:solidFill>
@@ -20521,8 +20521,8 @@
         </p:nvSpPr>
         <p:spPr>
           <a:xfrm>
-            <a:off x="6583680" y="1271016"/>
-            <a:ext cx="1965960" cy="201168"/>
+            <a:off x="5303520" y="1216152"/>
+            <a:ext cx="3246120" cy="384048"/>
           </a:xfrm>
           <a:prstGeom prst="rect">
             <a:avLst/>
@@ -20530,14 +20530,14 @@
           <a:noFill/>
         </p:spPr>
         <p:txBody>
-          <a:bodyPr wrap="square" lIns="0" rIns="0" tIns="0" bIns="0">
+          <a:bodyPr wrap="none" lIns="0" rIns="0" tIns="0" bIns="0">
             <a:noAutofit/>
           </a:bodyPr>
           <a:lstStyle/>
           <a:p>
-            <a:pPr algn="l">
-              <a:lnSpc>
-                <a:spcPct val="117000"/>
+            <a:pPr algn="r">
+              <a:lnSpc>
+                <a:spcPts val="2640"/>
               </a:lnSpc>
               <a:spcBef>
                 <a:spcPts val="0"/>
@@ -20554,7 +20554,7 @@
               </a:defRPr>
             </a:pPr>
             <a:r>
-              <a:rPr sz="1250" b="1" lang="ja-JP" altLang="en-US">
+              <a:rPr sz="2200" b="1" lang="ja-JP" altLang="en-US">
                 <a:solidFill>
                   <a:srgbClr val="2C9100"/>
                 </a:solidFill>
@@ -29303,8 +29303,8 @@
         </p:nvSpPr>
         <p:spPr>
           <a:xfrm>
-            <a:off x="6583680" y="1271016"/>
-            <a:ext cx="1965960" cy="201168"/>
+            <a:off x="5303520" y="1216152"/>
+            <a:ext cx="3246120" cy="384048"/>
           </a:xfrm>
           <a:prstGeom prst="rect">
             <a:avLst/>
@@ -29312,14 +29312,14 @@
           <a:noFill/>
         </p:spPr>
         <p:txBody>
-          <a:bodyPr wrap="square" lIns="0" rIns="0" tIns="0" bIns="0">
+          <a:bodyPr wrap="none" lIns="0" rIns="0" tIns="0" bIns="0">
             <a:noAutofit/>
           </a:bodyPr>
           <a:lstStyle/>
           <a:p>
-            <a:pPr algn="l">
-              <a:lnSpc>
-                <a:spcPct val="117000"/>
+            <a:pPr algn="r">
+              <a:lnSpc>
+                <a:spcPts val="2640"/>
               </a:lnSpc>
               <a:spcBef>
                 <a:spcPts val="0"/>
@@ -29336,7 +29336,7 @@
               </a:defRPr>
             </a:pPr>
             <a:r>
-              <a:rPr sz="1250" b="1" lang="ja-JP" altLang="en-US">
+              <a:rPr sz="2200" b="1" lang="ja-JP" altLang="en-US">
                 <a:solidFill>
                   <a:srgbClr val="2C9100"/>
                 </a:solidFill>
@@ -29916,8 +29916,8 @@
         </p:nvSpPr>
         <p:spPr>
           <a:xfrm>
-            <a:off x="6583680" y="1271016"/>
-            <a:ext cx="1965960" cy="201168"/>
+            <a:off x="5303520" y="1216152"/>
+            <a:ext cx="3246120" cy="384048"/>
           </a:xfrm>
           <a:prstGeom prst="rect">
             <a:avLst/>
@@ -29925,14 +29925,14 @@
           <a:noFill/>
         </p:spPr>
         <p:txBody>
-          <a:bodyPr wrap="square" lIns="0" rIns="0" tIns="0" bIns="0">
+          <a:bodyPr wrap="none" lIns="0" rIns="0" tIns="0" bIns="0">
             <a:noAutofit/>
           </a:bodyPr>
           <a:lstStyle/>
           <a:p>
-            <a:pPr algn="l">
-              <a:lnSpc>
-                <a:spcPct val="117000"/>
+            <a:pPr algn="r">
+              <a:lnSpc>
+                <a:spcPts val="2640"/>
               </a:lnSpc>
               <a:spcBef>
                 <a:spcPts val="0"/>
@@ -29949,7 +29949,7 @@
               </a:defRPr>
             </a:pPr>
             <a:r>
-              <a:rPr sz="1250" b="1" lang="ja-JP" altLang="en-US">
+              <a:rPr sz="2200" b="1" lang="ja-JP" altLang="en-US">
                 <a:solidFill>
                   <a:srgbClr val="2C9100"/>
                 </a:solidFill>
@@ -30529,8 +30529,8 @@
         </p:nvSpPr>
         <p:spPr>
           <a:xfrm>
-            <a:off x="6583680" y="1271016"/>
-            <a:ext cx="1965960" cy="201168"/>
+            <a:off x="5303520" y="1216152"/>
+            <a:ext cx="3246120" cy="384048"/>
           </a:xfrm>
           <a:prstGeom prst="rect">
             <a:avLst/>
@@ -30538,14 +30538,14 @@
           <a:noFill/>
         </p:spPr>
         <p:txBody>
-          <a:bodyPr wrap="square" lIns="0" rIns="0" tIns="0" bIns="0">
+          <a:bodyPr wrap="none" lIns="0" rIns="0" tIns="0" bIns="0">
             <a:noAutofit/>
           </a:bodyPr>
           <a:lstStyle/>
           <a:p>
-            <a:pPr algn="l">
-              <a:lnSpc>
-                <a:spcPct val="117000"/>
+            <a:pPr algn="r">
+              <a:lnSpc>
+                <a:spcPts val="2640"/>
               </a:lnSpc>
               <a:spcBef>
                 <a:spcPts val="0"/>
@@ -30562,7 +30562,7 @@
               </a:defRPr>
             </a:pPr>
             <a:r>
-              <a:rPr sz="1250" b="1" lang="ja-JP" altLang="en-US">
+              <a:rPr sz="2200" b="1" lang="ja-JP" altLang="en-US">
                 <a:solidFill>
                   <a:srgbClr val="2C9100"/>
                 </a:solidFill>

</xml_diff>

<commit_message>
slides(babi): use burgundy theme accent for answers
</commit_message>
<xml_diff>
--- a/slides/datasets-in-10-minutes-babi.pptx
+++ b/slides/datasets-in-10-minutes-babi.pptx
@@ -7475,7 +7475,7 @@
             <a:r>
               <a:rPr sz="2200" b="1" lang="ja-JP" altLang="en-US">
                 <a:solidFill>
-                  <a:srgbClr val="2C9100"/>
+                  <a:schemeClr val="accent1"/>
                 </a:solidFill>
                 <a:latin typeface="Noto Sans"/>
                 <a:ea typeface="Noto Sans CJK JP"/>
@@ -13556,7 +13556,7 @@
             <a:r>
               <a:rPr sz="2200" b="1" lang="ja-JP" altLang="en-US">
                 <a:solidFill>
-                  <a:srgbClr val="2C9100"/>
+                  <a:schemeClr val="accent1"/>
                 </a:solidFill>
                 <a:latin typeface="Noto Sans"/>
                 <a:ea typeface="Noto Sans CJK JP"/>
@@ -14169,7 +14169,7 @@
             <a:r>
               <a:rPr sz="2200" b="1" lang="ja-JP" altLang="en-US">
                 <a:solidFill>
-                  <a:srgbClr val="2C9100"/>
+                  <a:schemeClr val="accent1"/>
                 </a:solidFill>
                 <a:latin typeface="Noto Sans"/>
                 <a:ea typeface="Noto Sans CJK JP"/>
@@ -14915,7 +14915,7 @@
             <a:r>
               <a:rPr sz="2200" b="1" lang="ja-JP" altLang="en-US">
                 <a:solidFill>
-                  <a:srgbClr val="2C9100"/>
+                  <a:schemeClr val="accent1"/>
                 </a:solidFill>
                 <a:latin typeface="Noto Sans"/>
                 <a:ea typeface="Noto Sans CJK JP"/>
@@ -15528,7 +15528,7 @@
             <a:r>
               <a:rPr sz="2200" b="1" lang="ja-JP" altLang="en-US">
                 <a:solidFill>
-                  <a:srgbClr val="2C9100"/>
+                  <a:schemeClr val="accent1"/>
                 </a:solidFill>
                 <a:latin typeface="Noto Sans"/>
                 <a:ea typeface="Noto Sans CJK JP"/>
@@ -16141,7 +16141,7 @@
             <a:r>
               <a:rPr sz="2200" b="1" lang="ja-JP" altLang="en-US">
                 <a:solidFill>
-                  <a:srgbClr val="2C9100"/>
+                  <a:schemeClr val="accent1"/>
                 </a:solidFill>
                 <a:latin typeface="Noto Sans"/>
                 <a:ea typeface="Noto Sans CJK JP"/>
@@ -16754,7 +16754,7 @@
             <a:r>
               <a:rPr sz="2200" b="1" lang="ja-JP" altLang="en-US">
                 <a:solidFill>
-                  <a:srgbClr val="2C9100"/>
+                  <a:schemeClr val="accent1"/>
                 </a:solidFill>
                 <a:latin typeface="Noto Sans"/>
                 <a:ea typeface="Noto Sans CJK JP"/>
@@ -17367,7 +17367,7 @@
             <a:r>
               <a:rPr sz="2200" b="1" lang="ja-JP" altLang="en-US">
                 <a:solidFill>
-                  <a:srgbClr val="2C9100"/>
+                  <a:schemeClr val="accent1"/>
                 </a:solidFill>
                 <a:latin typeface="Noto Sans"/>
                 <a:ea typeface="Noto Sans CJK JP"/>
@@ -17980,7 +17980,7 @@
             <a:r>
               <a:rPr sz="2200" b="1" lang="ja-JP" altLang="en-US">
                 <a:solidFill>
-                  <a:srgbClr val="2C9100"/>
+                  <a:schemeClr val="accent1"/>
                 </a:solidFill>
                 <a:latin typeface="Noto Sans"/>
                 <a:ea typeface="Noto Sans CJK JP"/>
@@ -18593,7 +18593,7 @@
             <a:r>
               <a:rPr sz="2200" b="1" lang="ja-JP" altLang="en-US">
                 <a:solidFill>
-                  <a:srgbClr val="2C9100"/>
+                  <a:schemeClr val="accent1"/>
                 </a:solidFill>
                 <a:latin typeface="Noto Sans"/>
                 <a:ea typeface="Noto Sans CJK JP"/>
@@ -19206,7 +19206,7 @@
             <a:r>
               <a:rPr sz="2200" b="1" lang="ja-JP" altLang="en-US">
                 <a:solidFill>
-                  <a:srgbClr val="2C9100"/>
+                  <a:schemeClr val="accent1"/>
                 </a:solidFill>
                 <a:latin typeface="Noto Sans"/>
                 <a:ea typeface="Noto Sans CJK JP"/>
@@ -20067,7 +20067,7 @@
             <a:r>
               <a:rPr sz="2200" b="1" lang="ja-JP" altLang="en-US">
                 <a:solidFill>
-                  <a:srgbClr val="2C9100"/>
+                  <a:schemeClr val="accent1"/>
                 </a:solidFill>
                 <a:latin typeface="Noto Sans"/>
                 <a:ea typeface="Noto Sans CJK JP"/>
@@ -20556,7 +20556,7 @@
             <a:r>
               <a:rPr sz="2200" b="1" lang="ja-JP" altLang="en-US">
                 <a:solidFill>
-                  <a:srgbClr val="2C9100"/>
+                  <a:schemeClr val="accent1"/>
                 </a:solidFill>
                 <a:latin typeface="Noto Sans"/>
                 <a:ea typeface="Noto Sans CJK JP"/>
@@ -29338,7 +29338,7 @@
             <a:r>
               <a:rPr sz="2200" b="1" lang="ja-JP" altLang="en-US">
                 <a:solidFill>
-                  <a:srgbClr val="2C9100"/>
+                  <a:schemeClr val="accent1"/>
                 </a:solidFill>
                 <a:latin typeface="Noto Sans"/>
                 <a:ea typeface="Noto Sans CJK JP"/>
@@ -29951,7 +29951,7 @@
             <a:r>
               <a:rPr sz="2200" b="1" lang="ja-JP" altLang="en-US">
                 <a:solidFill>
-                  <a:srgbClr val="2C9100"/>
+                  <a:schemeClr val="accent1"/>
                 </a:solidFill>
                 <a:latin typeface="Noto Sans"/>
                 <a:ea typeface="Noto Sans CJK JP"/>
@@ -30564,7 +30564,7 @@
             <a:r>
               <a:rPr sz="2200" b="1" lang="ja-JP" altLang="en-US">
                 <a:solidFill>
-                  <a:srgbClr val="2C9100"/>
+                  <a:schemeClr val="accent1"/>
                 </a:solidFill>
                 <a:latin typeface="Noto Sans"/>
                 <a:ea typeface="Noto Sans CJK JP"/>

</xml_diff>